<commit_message>
applies some sorrection to the slides and lab solutions
</commit_message>
<xml_diff>
--- a/00-Introduction.pptx
+++ b/00-Introduction.pptx
@@ -3431,13 +3431,13 @@
       <dgm:prSet presAssocID="{1DE5140C-1F98-42BC-9EAC-4912A1F586B9}" presName="iconRect" presStyleLbl="node1" presStyleIdx="0" presStyleCnt="2"/>
       <dgm:spPr>
         <a:blipFill>
-          <a:blip xmlns:r="http://schemas.openxmlformats.org/officeDocument/2006/relationships" r:embed="rId1">
+          <a:blip xmlns:r="http://schemas.openxmlformats.org/officeDocument/2006/relationships">
             <a:extLst>
               <a:ext uri="{28A0092B-C50C-407E-A947-70E740481C1C}">
                 <a14:useLocalDpi xmlns:a14="http://schemas.microsoft.com/office/drawing/2010/main" val="0"/>
               </a:ext>
               <a:ext uri="{96DAC541-7B7A-43D3-8B79-37D633B846F1}">
-                <asvg:svgBlip xmlns:asvg="http://schemas.microsoft.com/office/drawing/2016/SVG/main" r:embed="rId2"/>
+                <asvg:svgBlip xmlns:asvg="http://schemas.microsoft.com/office/drawing/2016/SVG/main" r:embed="rId1"/>
               </a:ext>
             </a:extLst>
           </a:blip>
@@ -3490,13 +3490,13 @@
       <dgm:prSet presAssocID="{3749FA15-5310-4F2A-BC79-F44AB85435D1}" presName="iconRect" presStyleLbl="node1" presStyleIdx="1" presStyleCnt="2"/>
       <dgm:spPr>
         <a:blipFill>
-          <a:blip xmlns:r="http://schemas.openxmlformats.org/officeDocument/2006/relationships" r:embed="rId3">
+          <a:blip xmlns:r="http://schemas.openxmlformats.org/officeDocument/2006/relationships">
             <a:extLst>
               <a:ext uri="{28A0092B-C50C-407E-A947-70E740481C1C}">
                 <a14:useLocalDpi xmlns:a14="http://schemas.microsoft.com/office/drawing/2010/main" val="0"/>
               </a:ext>
               <a:ext uri="{96DAC541-7B7A-43D3-8B79-37D633B846F1}">
-                <asvg:svgBlip xmlns:asvg="http://schemas.microsoft.com/office/drawing/2016/SVG/main" r:embed="rId4"/>
+                <asvg:svgBlip xmlns:asvg="http://schemas.microsoft.com/office/drawing/2016/SVG/main" r:embed="rId2"/>
               </a:ext>
             </a:extLst>
           </a:blip>
@@ -3793,13 +3793,13 @@
       <dgm:prSet presAssocID="{E8ABA4EE-555A-45F9-BE83-960651B382BD}" presName="iconRect" presStyleLbl="node1" presStyleIdx="0" presStyleCnt="3"/>
       <dgm:spPr>
         <a:blipFill>
-          <a:blip xmlns:r="http://schemas.openxmlformats.org/officeDocument/2006/relationships" r:embed="rId1">
+          <a:blip xmlns:r="http://schemas.openxmlformats.org/officeDocument/2006/relationships">
             <a:extLst>
               <a:ext uri="{28A0092B-C50C-407E-A947-70E740481C1C}">
                 <a14:useLocalDpi xmlns:a14="http://schemas.microsoft.com/office/drawing/2010/main" val="0"/>
               </a:ext>
               <a:ext uri="{96DAC541-7B7A-43D3-8B79-37D633B846F1}">
-                <asvg:svgBlip xmlns:asvg="http://schemas.microsoft.com/office/drawing/2016/SVG/main" r:embed="rId2"/>
+                <asvg:svgBlip xmlns:asvg="http://schemas.microsoft.com/office/drawing/2016/SVG/main" r:embed="rId1"/>
               </a:ext>
             </a:extLst>
           </a:blip>
@@ -3846,13 +3846,13 @@
       <dgm:prSet presAssocID="{11F8D19B-4EF8-4B9B-9085-F4DA5B480ABC}" presName="iconRect" presStyleLbl="node1" presStyleIdx="1" presStyleCnt="3"/>
       <dgm:spPr>
         <a:blipFill>
-          <a:blip xmlns:r="http://schemas.openxmlformats.org/officeDocument/2006/relationships" r:embed="rId3">
+          <a:blip xmlns:r="http://schemas.openxmlformats.org/officeDocument/2006/relationships">
             <a:extLst>
               <a:ext uri="{28A0092B-C50C-407E-A947-70E740481C1C}">
                 <a14:useLocalDpi xmlns:a14="http://schemas.microsoft.com/office/drawing/2010/main" val="0"/>
               </a:ext>
               <a:ext uri="{96DAC541-7B7A-43D3-8B79-37D633B846F1}">
-                <asvg:svgBlip xmlns:asvg="http://schemas.microsoft.com/office/drawing/2016/SVG/main" r:embed="rId4"/>
+                <asvg:svgBlip xmlns:asvg="http://schemas.microsoft.com/office/drawing/2016/SVG/main" r:embed="rId2"/>
               </a:ext>
             </a:extLst>
           </a:blip>
@@ -3905,13 +3905,13 @@
       <dgm:prSet presAssocID="{CD2264CC-67C0-4349-A953-5908D75BC895}" presName="iconRect" presStyleLbl="node1" presStyleIdx="2" presStyleCnt="3"/>
       <dgm:spPr>
         <a:blipFill>
-          <a:blip xmlns:r="http://schemas.openxmlformats.org/officeDocument/2006/relationships" r:embed="rId5">
+          <a:blip xmlns:r="http://schemas.openxmlformats.org/officeDocument/2006/relationships">
             <a:extLst>
               <a:ext uri="{28A0092B-C50C-407E-A947-70E740481C1C}">
                 <a14:useLocalDpi xmlns:a14="http://schemas.microsoft.com/office/drawing/2010/main" val="0"/>
               </a:ext>
               <a:ext uri="{96DAC541-7B7A-43D3-8B79-37D633B846F1}">
-                <asvg:svgBlip xmlns:asvg="http://schemas.microsoft.com/office/drawing/2016/SVG/main" r:embed="rId6"/>
+                <asvg:svgBlip xmlns:asvg="http://schemas.microsoft.com/office/drawing/2016/SVG/main" r:embed="rId3"/>
               </a:ext>
             </a:extLst>
           </a:blip>
@@ -4515,10 +4515,10 @@
         <a:lstStyle/>
         <a:p>
           <a:r>
-            <a:rPr lang="en-GB" b="1"/>
-            <a:t>Coding experience</a:t>
+            <a:rPr lang="en-GB" b="1" dirty="0"/>
+            <a:t>Coding experience C#, OO</a:t>
           </a:r>
-          <a:endParaRPr lang="en-US" b="1"/>
+          <a:endParaRPr lang="en-US" b="1" dirty="0"/>
         </a:p>
       </dgm:t>
     </dgm:pt>
@@ -4639,10 +4639,10 @@
       <dgm:prSet presAssocID="{5FA4D89E-1172-405E-95DD-132537E5313D}" presName="iconRect" presStyleLbl="node1" presStyleIdx="0" presStyleCnt="5"/>
       <dgm:spPr>
         <a:blipFill>
-          <a:blip xmlns:r="http://schemas.openxmlformats.org/officeDocument/2006/relationships" r:embed="rId1">
+          <a:blip xmlns:r="http://schemas.openxmlformats.org/officeDocument/2006/relationships">
             <a:extLst>
               <a:ext uri="{96DAC541-7B7A-43D3-8B79-37D633B846F1}">
-                <asvg:svgBlip xmlns:asvg="http://schemas.microsoft.com/office/drawing/2016/SVG/main" r:embed="rId2"/>
+                <asvg:svgBlip xmlns:asvg="http://schemas.microsoft.com/office/drawing/2016/SVG/main" r:embed="rId1"/>
               </a:ext>
             </a:extLst>
           </a:blip>
@@ -4690,13 +4690,13 @@
       <dgm:prSet presAssocID="{39CF8EED-6256-4DFD-AC75-08C6FE784F45}" presName="iconRect" presStyleLbl="node1" presStyleIdx="1" presStyleCnt="5"/>
       <dgm:spPr>
         <a:blipFill>
-          <a:blip xmlns:r="http://schemas.openxmlformats.org/officeDocument/2006/relationships" r:embed="rId3">
+          <a:blip xmlns:r="http://schemas.openxmlformats.org/officeDocument/2006/relationships">
             <a:extLst>
               <a:ext uri="{28A0092B-C50C-407E-A947-70E740481C1C}">
                 <a14:useLocalDpi xmlns:a14="http://schemas.microsoft.com/office/drawing/2010/main" val="0"/>
               </a:ext>
               <a:ext uri="{96DAC541-7B7A-43D3-8B79-37D633B846F1}">
-                <asvg:svgBlip xmlns:asvg="http://schemas.microsoft.com/office/drawing/2016/SVG/main" r:embed="rId4"/>
+                <asvg:svgBlip xmlns:asvg="http://schemas.microsoft.com/office/drawing/2016/SVG/main" r:embed="rId2"/>
               </a:ext>
             </a:extLst>
           </a:blip>
@@ -4743,13 +4743,13 @@
       <dgm:prSet presAssocID="{1737F8E3-5FD3-4504-8212-DB92B80ABC7A}" presName="iconRect" presStyleLbl="node1" presStyleIdx="2" presStyleCnt="5"/>
       <dgm:spPr>
         <a:blipFill>
-          <a:blip xmlns:r="http://schemas.openxmlformats.org/officeDocument/2006/relationships" r:embed="rId5">
+          <a:blip xmlns:r="http://schemas.openxmlformats.org/officeDocument/2006/relationships">
             <a:extLst>
               <a:ext uri="{28A0092B-C50C-407E-A947-70E740481C1C}">
                 <a14:useLocalDpi xmlns:a14="http://schemas.microsoft.com/office/drawing/2010/main" val="0"/>
               </a:ext>
               <a:ext uri="{96DAC541-7B7A-43D3-8B79-37D633B846F1}">
-                <asvg:svgBlip xmlns:asvg="http://schemas.microsoft.com/office/drawing/2016/SVG/main" r:embed="rId6"/>
+                <asvg:svgBlip xmlns:asvg="http://schemas.microsoft.com/office/drawing/2016/SVG/main" r:embed="rId3"/>
               </a:ext>
             </a:extLst>
           </a:blip>
@@ -4796,13 +4796,13 @@
       <dgm:prSet presAssocID="{6D8FF53F-EB59-4015-939C-0BCFB04B6916}" presName="iconRect" presStyleLbl="node1" presStyleIdx="3" presStyleCnt="5"/>
       <dgm:spPr>
         <a:blipFill>
-          <a:blip xmlns:r="http://schemas.openxmlformats.org/officeDocument/2006/relationships" r:embed="rId7">
+          <a:blip xmlns:r="http://schemas.openxmlformats.org/officeDocument/2006/relationships">
             <a:extLst>
               <a:ext uri="{28A0092B-C50C-407E-A947-70E740481C1C}">
                 <a14:useLocalDpi xmlns:a14="http://schemas.microsoft.com/office/drawing/2010/main" val="0"/>
               </a:ext>
               <a:ext uri="{96DAC541-7B7A-43D3-8B79-37D633B846F1}">
-                <asvg:svgBlip xmlns:asvg="http://schemas.microsoft.com/office/drawing/2016/SVG/main" r:embed="rId8"/>
+                <asvg:svgBlip xmlns:asvg="http://schemas.microsoft.com/office/drawing/2016/SVG/main" r:embed="rId4"/>
               </a:ext>
             </a:extLst>
           </a:blip>
@@ -4849,13 +4849,13 @@
       <dgm:prSet presAssocID="{AE6D27D1-F778-4E00-A18C-81EDB378111B}" presName="iconRect" presStyleLbl="node1" presStyleIdx="4" presStyleCnt="5"/>
       <dgm:spPr>
         <a:blipFill>
-          <a:blip xmlns:r="http://schemas.openxmlformats.org/officeDocument/2006/relationships" r:embed="rId9">
+          <a:blip xmlns:r="http://schemas.openxmlformats.org/officeDocument/2006/relationships">
             <a:extLst>
               <a:ext uri="{28A0092B-C50C-407E-A947-70E740481C1C}">
                 <a14:useLocalDpi xmlns:a14="http://schemas.microsoft.com/office/drawing/2010/main" val="0"/>
               </a:ext>
               <a:ext uri="{96DAC541-7B7A-43D3-8B79-37D633B846F1}">
-                <asvg:svgBlip xmlns:asvg="http://schemas.microsoft.com/office/drawing/2016/SVG/main" r:embed="rId10"/>
+                <asvg:svgBlip xmlns:asvg="http://schemas.microsoft.com/office/drawing/2016/SVG/main" r:embed="rId5"/>
               </a:ext>
             </a:extLst>
           </a:blip>
@@ -4961,13 +4961,13 @@
           <a:avLst/>
         </a:prstGeom>
         <a:blipFill>
-          <a:blip xmlns:r="http://schemas.openxmlformats.org/officeDocument/2006/relationships" r:embed="rId1">
+          <a:blip xmlns:r="http://schemas.openxmlformats.org/officeDocument/2006/relationships">
             <a:extLst>
               <a:ext uri="{28A0092B-C50C-407E-A947-70E740481C1C}">
                 <a14:useLocalDpi xmlns:a14="http://schemas.microsoft.com/office/drawing/2010/main" val="0"/>
               </a:ext>
               <a:ext uri="{96DAC541-7B7A-43D3-8B79-37D633B846F1}">
-                <asvg:svgBlip xmlns:asvg="http://schemas.microsoft.com/office/drawing/2016/SVG/main" r:embed="rId2"/>
+                <asvg:svgBlip xmlns:asvg="http://schemas.microsoft.com/office/drawing/2016/SVG/main" r:embed="rId1"/>
               </a:ext>
             </a:extLst>
           </a:blip>
@@ -5141,13 +5141,13 @@
           <a:avLst/>
         </a:prstGeom>
         <a:blipFill>
-          <a:blip xmlns:r="http://schemas.openxmlformats.org/officeDocument/2006/relationships" r:embed="rId3">
+          <a:blip xmlns:r="http://schemas.openxmlformats.org/officeDocument/2006/relationships">
             <a:extLst>
               <a:ext uri="{28A0092B-C50C-407E-A947-70E740481C1C}">
                 <a14:useLocalDpi xmlns:a14="http://schemas.microsoft.com/office/drawing/2010/main" val="0"/>
               </a:ext>
               <a:ext uri="{96DAC541-7B7A-43D3-8B79-37D633B846F1}">
-                <asvg:svgBlip xmlns:asvg="http://schemas.microsoft.com/office/drawing/2016/SVG/main" r:embed="rId4"/>
+                <asvg:svgBlip xmlns:asvg="http://schemas.microsoft.com/office/drawing/2016/SVG/main" r:embed="rId2"/>
               </a:ext>
             </a:extLst>
           </a:blip>
@@ -5406,13 +5406,13 @@
           <a:avLst/>
         </a:prstGeom>
         <a:blipFill>
-          <a:blip xmlns:r="http://schemas.openxmlformats.org/officeDocument/2006/relationships" r:embed="rId1">
+          <a:blip xmlns:r="http://schemas.openxmlformats.org/officeDocument/2006/relationships">
             <a:extLst>
               <a:ext uri="{28A0092B-C50C-407E-A947-70E740481C1C}">
                 <a14:useLocalDpi xmlns:a14="http://schemas.microsoft.com/office/drawing/2010/main" val="0"/>
               </a:ext>
               <a:ext uri="{96DAC541-7B7A-43D3-8B79-37D633B846F1}">
-                <asvg:svgBlip xmlns:asvg="http://schemas.microsoft.com/office/drawing/2016/SVG/main" r:embed="rId2"/>
+                <asvg:svgBlip xmlns:asvg="http://schemas.microsoft.com/office/drawing/2016/SVG/main" r:embed="rId1"/>
               </a:ext>
             </a:extLst>
           </a:blip>
@@ -5559,13 +5559,13 @@
           <a:avLst/>
         </a:prstGeom>
         <a:blipFill>
-          <a:blip xmlns:r="http://schemas.openxmlformats.org/officeDocument/2006/relationships" r:embed="rId3">
+          <a:blip xmlns:r="http://schemas.openxmlformats.org/officeDocument/2006/relationships">
             <a:extLst>
               <a:ext uri="{28A0092B-C50C-407E-A947-70E740481C1C}">
                 <a14:useLocalDpi xmlns:a14="http://schemas.microsoft.com/office/drawing/2010/main" val="0"/>
               </a:ext>
               <a:ext uri="{96DAC541-7B7A-43D3-8B79-37D633B846F1}">
-                <asvg:svgBlip xmlns:asvg="http://schemas.microsoft.com/office/drawing/2016/SVG/main" r:embed="rId4"/>
+                <asvg:svgBlip xmlns:asvg="http://schemas.microsoft.com/office/drawing/2016/SVG/main" r:embed="rId2"/>
               </a:ext>
             </a:extLst>
           </a:blip>
@@ -5807,13 +5807,13 @@
           <a:avLst/>
         </a:prstGeom>
         <a:blipFill>
-          <a:blip xmlns:r="http://schemas.openxmlformats.org/officeDocument/2006/relationships" r:embed="rId5">
+          <a:blip xmlns:r="http://schemas.openxmlformats.org/officeDocument/2006/relationships">
             <a:extLst>
               <a:ext uri="{28A0092B-C50C-407E-A947-70E740481C1C}">
                 <a14:useLocalDpi xmlns:a14="http://schemas.microsoft.com/office/drawing/2010/main" val="0"/>
               </a:ext>
               <a:ext uri="{96DAC541-7B7A-43D3-8B79-37D633B846F1}">
-                <asvg:svgBlip xmlns:asvg="http://schemas.microsoft.com/office/drawing/2016/SVG/main" r:embed="rId6"/>
+                <asvg:svgBlip xmlns:asvg="http://schemas.microsoft.com/office/drawing/2016/SVG/main" r:embed="rId3"/>
               </a:ext>
             </a:extLst>
           </a:blip>
@@ -6563,10 +6563,10 @@
           <a:avLst/>
         </a:prstGeom>
         <a:blipFill>
-          <a:blip xmlns:r="http://schemas.openxmlformats.org/officeDocument/2006/relationships" r:embed="rId1">
+          <a:blip xmlns:r="http://schemas.openxmlformats.org/officeDocument/2006/relationships">
             <a:extLst>
               <a:ext uri="{96DAC541-7B7A-43D3-8B79-37D633B846F1}">
-                <asvg:svgBlip xmlns:asvg="http://schemas.microsoft.com/office/drawing/2016/SVG/main" r:embed="rId2"/>
+                <asvg:svgBlip xmlns:asvg="http://schemas.microsoft.com/office/drawing/2016/SVG/main" r:embed="rId1"/>
               </a:ext>
             </a:extLst>
           </a:blip>
@@ -6714,13 +6714,13 @@
           <a:avLst/>
         </a:prstGeom>
         <a:blipFill>
-          <a:blip xmlns:r="http://schemas.openxmlformats.org/officeDocument/2006/relationships" r:embed="rId3">
+          <a:blip xmlns:r="http://schemas.openxmlformats.org/officeDocument/2006/relationships">
             <a:extLst>
               <a:ext uri="{28A0092B-C50C-407E-A947-70E740481C1C}">
                 <a14:useLocalDpi xmlns:a14="http://schemas.microsoft.com/office/drawing/2010/main" val="0"/>
               </a:ext>
               <a:ext uri="{96DAC541-7B7A-43D3-8B79-37D633B846F1}">
-                <asvg:svgBlip xmlns:asvg="http://schemas.microsoft.com/office/drawing/2016/SVG/main" r:embed="rId4"/>
+                <asvg:svgBlip xmlns:asvg="http://schemas.microsoft.com/office/drawing/2016/SVG/main" r:embed="rId2"/>
               </a:ext>
             </a:extLst>
           </a:blip>
@@ -6867,13 +6867,13 @@
           <a:avLst/>
         </a:prstGeom>
         <a:blipFill>
-          <a:blip xmlns:r="http://schemas.openxmlformats.org/officeDocument/2006/relationships" r:embed="rId5">
+          <a:blip xmlns:r="http://schemas.openxmlformats.org/officeDocument/2006/relationships">
             <a:extLst>
               <a:ext uri="{28A0092B-C50C-407E-A947-70E740481C1C}">
                 <a14:useLocalDpi xmlns:a14="http://schemas.microsoft.com/office/drawing/2010/main" val="0"/>
               </a:ext>
               <a:ext uri="{96DAC541-7B7A-43D3-8B79-37D633B846F1}">
-                <asvg:svgBlip xmlns:asvg="http://schemas.microsoft.com/office/drawing/2016/SVG/main" r:embed="rId6"/>
+                <asvg:svgBlip xmlns:asvg="http://schemas.microsoft.com/office/drawing/2016/SVG/main" r:embed="rId3"/>
               </a:ext>
             </a:extLst>
           </a:blip>
@@ -6953,10 +6953,10 @@
             <a:buNone/>
           </a:pPr>
           <a:r>
-            <a:rPr lang="en-GB" sz="1900" b="1" kern="1200"/>
-            <a:t>Coding experience</a:t>
+            <a:rPr lang="en-GB" sz="1900" b="1" kern="1200" dirty="0"/>
+            <a:t>Coding experience C#, OO</a:t>
           </a:r>
-          <a:endParaRPr lang="en-US" sz="1900" b="1" kern="1200"/>
+          <a:endParaRPr lang="en-US" sz="1900" b="1" kern="1200" dirty="0"/>
         </a:p>
       </dsp:txBody>
       <dsp:txXfrm>
@@ -7020,13 +7020,13 @@
           <a:avLst/>
         </a:prstGeom>
         <a:blipFill>
-          <a:blip xmlns:r="http://schemas.openxmlformats.org/officeDocument/2006/relationships" r:embed="rId7">
+          <a:blip xmlns:r="http://schemas.openxmlformats.org/officeDocument/2006/relationships">
             <a:extLst>
               <a:ext uri="{28A0092B-C50C-407E-A947-70E740481C1C}">
                 <a14:useLocalDpi xmlns:a14="http://schemas.microsoft.com/office/drawing/2010/main" val="0"/>
               </a:ext>
               <a:ext uri="{96DAC541-7B7A-43D3-8B79-37D633B846F1}">
-                <asvg:svgBlip xmlns:asvg="http://schemas.microsoft.com/office/drawing/2016/SVG/main" r:embed="rId8"/>
+                <asvg:svgBlip xmlns:asvg="http://schemas.microsoft.com/office/drawing/2016/SVG/main" r:embed="rId4"/>
               </a:ext>
             </a:extLst>
           </a:blip>
@@ -7173,13 +7173,13 @@
           <a:avLst/>
         </a:prstGeom>
         <a:blipFill>
-          <a:blip xmlns:r="http://schemas.openxmlformats.org/officeDocument/2006/relationships" r:embed="rId9">
+          <a:blip xmlns:r="http://schemas.openxmlformats.org/officeDocument/2006/relationships">
             <a:extLst>
               <a:ext uri="{28A0092B-C50C-407E-A947-70E740481C1C}">
                 <a14:useLocalDpi xmlns:a14="http://schemas.microsoft.com/office/drawing/2010/main" val="0"/>
               </a:ext>
               <a:ext uri="{96DAC541-7B7A-43D3-8B79-37D633B846F1}">
-                <asvg:svgBlip xmlns:asvg="http://schemas.microsoft.com/office/drawing/2016/SVG/main" r:embed="rId10"/>
+                <asvg:svgBlip xmlns:asvg="http://schemas.microsoft.com/office/drawing/2016/SVG/main" r:embed="rId5"/>
               </a:ext>
             </a:extLst>
           </a:blip>
@@ -12456,7 +12456,7 @@
           <a:p>
             <a:fld id="{86D088FE-3E68-47FE-8BA4-634CD34BABBC}" type="datetimeFigureOut">
               <a:rPr lang="en-GB" smtClean="0"/>
-              <a:t>05/12/2025</a:t>
+              <a:t>03/08/2026</a:t>
             </a:fld>
             <a:endParaRPr lang="en-GB"/>
           </a:p>
@@ -12627,7 +12627,7 @@
             <a:fld id="{1D6B66C6-1E92-0F4E-A300-9D4ED1F0C23F}" type="datetimeFigureOut">
               <a:rPr lang="en-GB" smtClean="0"/>
               <a:pPr/>
-              <a:t>05/12/2025</a:t>
+              <a:t>03/08/2026</a:t>
             </a:fld>
             <a:endParaRPr lang="en-GB"/>
           </a:p>
@@ -13704,13 +13704,13 @@
           <p:nvPr userDrawn="1"/>
         </p:nvPicPr>
         <p:blipFill>
-          <a:blip r:embed="rId3">
+          <a:blip>
             <a:extLst>
               <a:ext uri="{28A0092B-C50C-407E-A947-70E740481C1C}">
                 <a14:useLocalDpi xmlns:a14="http://schemas.microsoft.com/office/drawing/2010/main" val="0"/>
               </a:ext>
               <a:ext uri="{96DAC541-7B7A-43D3-8B79-37D633B846F1}">
-                <asvg:svgBlip xmlns:asvg="http://schemas.microsoft.com/office/drawing/2016/SVG/main" r:embed="rId4"/>
+                <asvg:svgBlip xmlns:asvg="http://schemas.microsoft.com/office/drawing/2016/SVG/main" r:embed="rId3"/>
               </a:ext>
             </a:extLst>
           </a:blip>
@@ -22091,13 +22091,13 @@
           <p:nvPr userDrawn="1"/>
         </p:nvPicPr>
         <p:blipFill>
-          <a:blip r:embed="rId3">
+          <a:blip>
             <a:extLst>
               <a:ext uri="{28A0092B-C50C-407E-A947-70E740481C1C}">
                 <a14:useLocalDpi xmlns:a14="http://schemas.microsoft.com/office/drawing/2010/main" val="0"/>
               </a:ext>
               <a:ext uri="{96DAC541-7B7A-43D3-8B79-37D633B846F1}">
-                <asvg:svgBlip xmlns:asvg="http://schemas.microsoft.com/office/drawing/2016/SVG/main" r:embed="rId4"/>
+                <asvg:svgBlip xmlns:asvg="http://schemas.microsoft.com/office/drawing/2016/SVG/main" r:embed="rId3"/>
               </a:ext>
             </a:extLst>
           </a:blip>
@@ -29268,13 +29268,13 @@
           <p:nvPr userDrawn="1"/>
         </p:nvPicPr>
         <p:blipFill>
-          <a:blip r:embed="rId3">
+          <a:blip>
             <a:extLst>
               <a:ext uri="{28A0092B-C50C-407E-A947-70E740481C1C}">
                 <a14:useLocalDpi xmlns:a14="http://schemas.microsoft.com/office/drawing/2010/main" val="0"/>
               </a:ext>
               <a:ext uri="{96DAC541-7B7A-43D3-8B79-37D633B846F1}">
-                <asvg:svgBlip xmlns:asvg="http://schemas.microsoft.com/office/drawing/2016/SVG/main" r:embed="rId4"/>
+                <asvg:svgBlip xmlns:asvg="http://schemas.microsoft.com/office/drawing/2016/SVG/main" r:embed="rId3"/>
               </a:ext>
             </a:extLst>
           </a:blip>
@@ -31895,13 +31895,13 @@
           <p:nvPr userDrawn="1"/>
         </p:nvPicPr>
         <p:blipFill>
-          <a:blip r:embed="rId3">
+          <a:blip>
             <a:extLst>
               <a:ext uri="{28A0092B-C50C-407E-A947-70E740481C1C}">
                 <a14:useLocalDpi xmlns:a14="http://schemas.microsoft.com/office/drawing/2010/main" val="0"/>
               </a:ext>
               <a:ext uri="{96DAC541-7B7A-43D3-8B79-37D633B846F1}">
-                <asvg:svgBlip xmlns:asvg="http://schemas.microsoft.com/office/drawing/2016/SVG/main" r:embed="rId4"/>
+                <asvg:svgBlip xmlns:asvg="http://schemas.microsoft.com/office/drawing/2016/SVG/main" r:embed="rId3"/>
               </a:ext>
             </a:extLst>
           </a:blip>
@@ -33430,13 +33430,13 @@
           <p:nvPr userDrawn="1"/>
         </p:nvPicPr>
         <p:blipFill>
-          <a:blip r:embed="rId3">
+          <a:blip>
             <a:extLst>
               <a:ext uri="{28A0092B-C50C-407E-A947-70E740481C1C}">
                 <a14:useLocalDpi xmlns:a14="http://schemas.microsoft.com/office/drawing/2010/main" val="0"/>
               </a:ext>
               <a:ext uri="{96DAC541-7B7A-43D3-8B79-37D633B846F1}">
-                <asvg:svgBlip xmlns:asvg="http://schemas.microsoft.com/office/drawing/2016/SVG/main" r:embed="rId4"/>
+                <asvg:svgBlip xmlns:asvg="http://schemas.microsoft.com/office/drawing/2016/SVG/main" r:embed="rId3"/>
               </a:ext>
             </a:extLst>
           </a:blip>
@@ -39126,7 +39126,7 @@
           <p:nvPr>
             <p:extLst>
               <p:ext uri="{D42A27DB-BD31-4B8C-83A1-F6EECF244321}">
-                <p14:modId xmlns:p14="http://schemas.microsoft.com/office/powerpoint/2010/main" val="4012979886"/>
+                <p14:modId xmlns:p14="http://schemas.microsoft.com/office/powerpoint/2010/main" val="1932952764"/>
               </p:ext>
             </p:extLst>
           </p:nvPr>
@@ -40056,6 +40056,15 @@
 </file>
 
 <file path=customXml/item1.xml><?xml version="1.0" encoding="utf-8"?>
+<?mso-contentType ?>
+<FormTemplates xmlns="http://schemas.microsoft.com/sharepoint/v3/contenttype/forms">
+  <Display>DocumentLibraryForm</Display>
+  <Edit>DocumentLibraryForm</Edit>
+  <New>DocumentLibraryForm</New>
+</FormTemplates>
+</file>
+
+<file path=customXml/item2.xml><?xml version="1.0" encoding="utf-8"?>
 <ct:contentTypeSchema xmlns:ct="http://schemas.microsoft.com/office/2006/metadata/contentType" xmlns:ma="http://schemas.microsoft.com/office/2006/metadata/properties/metaAttributes" ct:_="" ma:_="" ma:contentTypeName="Courseware" ma:contentTypeID="0x010100F0967B7CEE8D417F966757887D9466FB00B3EF5B1D149FDF49B1880C030D548140" ma:contentTypeVersion="0" ma:contentTypeDescription="Base content type which represents courseware documents" ma:contentTypeScope="" ma:versionID="ab0d7ca79e0ea5a537b031f986da336c">
   <xsd:schema xmlns:xsd="http://www.w3.org/2001/XMLSchema" xmlns:xs="http://www.w3.org/2001/XMLSchema" xmlns:p="http://schemas.microsoft.com/office/2006/metadata/properties" xmlns:ns2="6794D9DE-4FDF-4DC0-8B2C-5438320C69D5" targetNamespace="http://schemas.microsoft.com/office/2006/metadata/properties" ma:root="true" ma:fieldsID="7ff8e7c62cc10108c036e94c947d8fb9" ns2:_="">
     <xsd:import namespace="6794D9DE-4FDF-4DC0-8B2C-5438320C69D5"/>
@@ -40195,15 +40204,6 @@
 </ct:contentTypeSchema>
 </file>
 
-<file path=customXml/item2.xml><?xml version="1.0" encoding="utf-8"?>
-<?mso-contentType ?>
-<FormTemplates xmlns="http://schemas.microsoft.com/sharepoint/v3/contenttype/forms">
-  <Display>DocumentLibraryForm</Display>
-  <Edit>DocumentLibraryForm</Edit>
-  <New>DocumentLibraryForm</New>
-</FormTemplates>
-</file>
-
 <file path=customXml/item3.xml><?xml version="1.0" encoding="utf-8"?>
 <p:properties xmlns:p="http://schemas.microsoft.com/office/2006/metadata/properties" xmlns:xsi="http://www.w3.org/2001/XMLSchema-instance" xmlns:pc="http://schemas.microsoft.com/office/infopath/2007/PartnerControls">
   <documentManagement>
@@ -40222,6 +40222,14 @@
 </file>
 
 <file path=customXml/itemProps1.xml><?xml version="1.0" encoding="utf-8"?>
+<ds:datastoreItem xmlns:ds="http://schemas.openxmlformats.org/officeDocument/2006/customXml" ds:itemID="{29DAB023-16FF-451F-92AF-75688FACFE2D}">
+  <ds:schemaRefs>
+    <ds:schemaRef ds:uri="http://schemas.microsoft.com/sharepoint/v3/contenttype/forms"/>
+  </ds:schemaRefs>
+</ds:datastoreItem>
+</file>
+
+<file path=customXml/itemProps2.xml><?xml version="1.0" encoding="utf-8"?>
 <ds:datastoreItem xmlns:ds="http://schemas.openxmlformats.org/officeDocument/2006/customXml" ds:itemID="{9BF96F35-93DA-445D-9A2E-C702439F5B46}">
   <ds:schemaRefs>
     <ds:schemaRef ds:uri="http://schemas.microsoft.com/office/2006/metadata/contentType"/>
@@ -40235,14 +40243,6 @@
     <ds:schemaRef ds:uri="http://purl.org/dc/elements/1.1/"/>
     <ds:schemaRef ds:uri="http://purl.org/dc/terms/"/>
     <ds:schemaRef ds:uri="http://schemas.microsoft.com/internal/obd"/>
-  </ds:schemaRefs>
-</ds:datastoreItem>
-</file>
-
-<file path=customXml/itemProps2.xml><?xml version="1.0" encoding="utf-8"?>
-<ds:datastoreItem xmlns:ds="http://schemas.openxmlformats.org/officeDocument/2006/customXml" ds:itemID="{29DAB023-16FF-451F-92AF-75688FACFE2D}">
-  <ds:schemaRefs>
-    <ds:schemaRef ds:uri="http://schemas.microsoft.com/sharepoint/v3/contenttype/forms"/>
   </ds:schemaRefs>
 </ds:datastoreItem>
 </file>

</xml_diff>